<commit_message>
Remplacer les pôles par les six piliers stratégiques d’ADEB LONODJI
Référentiel institutionnel du 6 octobre 2026, rattachement unique des 22 thématiques, pages FR/EN, candidatures et documents courants. Les nominations et textes historiques datés restent traçables.
</commit_message>
<xml_diff>
--- a/public/odeb/odeb-lonodji-presentation-assemblee-2026.pptx
+++ b/public/odeb/odeb-lonodji-presentation-assemblee-2026.pptx
@@ -2871,7 +2871,7 @@
       </p:grpSpPr>
       <p:pic>
         <p:nvPicPr>
-          <p:cNvPr id="2" name="Image 0" descr="/home/claude/Lonodji/public/odeb/identite/odeb-lonodji-embleme-superposable-512.png">    </p:cNvPr>
+          <p:cNvPr id="2" name="Image 0" descr="/workspace/scratch/45770fcbf08b/lonodji/public/odeb/identite/odeb-lonodji-embleme-superposable-512.png">    </p:cNvPr>
           <p:cNvPicPr>
             <a:picLocks noChangeAspect="1"/>
           </p:cNvPicPr>
@@ -2927,7 +2927,7 @@
       </p:grpSpPr>
       <p:pic>
         <p:nvPicPr>
-          <p:cNvPr id="2" name="Image 0" descr="/home/claude/Lonodji/public/odeb/identite/odeb-lonodji-embleme-clair-superposable-512.png">    </p:cNvPr>
+          <p:cNvPr id="2" name="Image 0" descr="/workspace/scratch/45770fcbf08b/lonodji/public/odeb/identite/odeb-lonodji-embleme-clair-superposable-512.png">    </p:cNvPr>
           <p:cNvPicPr>
             <a:picLocks noChangeAspect="1"/>
           </p:cNvPicPr>
@@ -3256,7 +3256,7 @@
       </p:grpSpPr>
       <p:pic>
         <p:nvPicPr>
-          <p:cNvPr id="2" name="Image 0" descr="/home/claude/Lonodji/public/odeb/identite/odeb-lonodji-logo-horizontal-superposable-1000.png">    </p:cNvPr>
+          <p:cNvPr id="2" name="Image 0" descr="/workspace/scratch/45770fcbf08b/lonodji/public/odeb/identite/odeb-lonodji-logo-horizontal-superposable-1000.png">    </p:cNvPr>
           <p:cNvPicPr>
             <a:picLocks noChangeAspect="1"/>
           </p:cNvPicPr>
@@ -3817,7 +3817,7 @@
                 <a:ea typeface="DM Sans" pitchFamily="34" charset="-122"/>
                 <a:cs typeface="DM Sans" pitchFamily="34" charset="-120"/>
               </a:rPr>
-              <a:t>Le programme donne au pays bedjond ce qu’aucune structure ne lui assure aujourd’hui : un lieu où la connaissance se rassemble, se vérifie et se publie. Il s’appuie sur la thématique Recherche &amp; savoirs, sur les neuf chercheurs déjà recensés par la bibliothèque et sur la règle de preuve du site — chaque chiffre avec sa source, chaque erreur corrigée à découvert.</a:t>
+              <a:t>Le programme donne au pays bedjond ce qu’aucune structure ne lui assure aujourd’hui : un lieu où la connaissance se rassemble, se vérifie et se publie. Il s’appuie sur la thématique Recherche et enseignement supérieur, sur les neuf chercheurs déjà recensés par la bibliothèque et sur la règle de preuve du site — chaque chiffre avec sa source, chaque erreur corrigée à découvert.</a:t>
             </a:r>
             <a:endParaRPr lang="en-US" sz="1250" dirty="0"/>
           </a:p>
@@ -4802,7 +4802,7 @@
                 <a:ea typeface="DM Sans" pitchFamily="34" charset="-122"/>
                 <a:cs typeface="DM Sans" pitchFamily="34" charset="-120"/>
               </a:rPr>
-              <a:t>Le programme fait du diagnostic territorial une fonction permanente : des données village par village, des diagnostics tenus à jour, un observatoire qui suit les besoins signalés jusqu’à leur résolution et les plaidoyers jusqu’à leur réponse. Il s’appuie sur les pôles II et V de l’association et sur le pôle III : Gouvernance &amp; plaidoyer, et, depuis le 1er octobre 2026, Paix &amp; cohésion — les conflits entre agriculteurs et éleveurs, la médiation — et Justice &amp; droits humains — l’accès au droit et à l’état civil.</a:t>
+              <a:t>Le programme fait du diagnostic territorial une fonction permanente : des données village par village, des diagnostics tenus à jour, un observatoire qui suit les besoins signalés jusqu’à leur résolution et les plaidoyers jusqu’à leur réponse. Il s’appuie sur les piliers III (Services essentiels et développement territorial), IV (Économie inclusive et prospérité locale) et VI (Gouvernance, paix et partenariats) : services de base, développement local, médiation et prévention des conflits, accès au droit et à l’état civil.</a:t>
             </a:r>
             <a:endParaRPr lang="en-US" sz="1250" dirty="0"/>
           </a:p>
@@ -5787,7 +5787,7 @@
                 <a:ea typeface="DM Sans" pitchFamily="34" charset="-122"/>
                 <a:cs typeface="DM Sans" pitchFamily="34" charset="-120"/>
               </a:rPr>
-              <a:t>Le programme s’adresse aux jeunes de Bédjondo et de ses cantons : apprendre, se former, entreprendre, sans quitter le pays bedjond pour cela. Il réunit la thématique Éducation, jeunesse &amp; formation, les trois thématiques du pôle Numérique &amp; innovation et la thématique Entrepreneuriat &amp; finance inclusive, ainsi que l’espace numérique communautaire, premier chantier de l’association.</a:t>
+              <a:t>Le programme s’adresse aux jeunes de Bédjondo et de ses cantons : apprendre, se former, entreprendre, sans quitter le pays bedjond pour cela. Il réunit la thématique Éducation et formation professionnelle, les thématiques TIC et connectivité, Données et intelligence artificielle, Compétences numériques et emploi des jeunes et la thématique Moyens d’existence et inclusion financière, ainsi que l’espace numérique communautaire, premier chantier de l’association.</a:t>
             </a:r>
             <a:endParaRPr lang="en-US" sz="1250" dirty="0"/>
           </a:p>
@@ -6772,7 +6772,7 @@
                 <a:ea typeface="DM Sans" pitchFamily="34" charset="-122"/>
                 <a:cs typeface="DM Sans" pitchFamily="34" charset="-120"/>
               </a:rPr>
-              <a:t>Le programme organise ce que la diaspora bedjond peut apporter — du savoir, du temps, des moyens — et ce qu’elle est en droit d’attendre en retour : des comptes, des preuves, des résultats. Il s’appuie sur le répertoire des compétences ouvert en septembre 2026 et sur la thématique Réseau d’experts &amp; diaspora.</a:t>
+              <a:t>Le programme organise ce que la diaspora bedjond peut apporter — du savoir, du temps, des moyens — et ce qu’elle est en droit d’attendre en retour : des comptes, des preuves, des résultats. Il s’appuie sur le répertoire des compétences ouvert en septembre 2026 et sur la thématique Diaspora et partenariats.</a:t>
             </a:r>
             <a:endParaRPr lang="en-US" sz="1250" dirty="0"/>
           </a:p>
@@ -10747,7 +10747,7 @@
                 <a:ea typeface="Playfair Display" pitchFamily="34" charset="-122"/>
                 <a:cs typeface="Playfair Display" pitchFamily="34" charset="-120"/>
               </a:rPr>
-              <a:t>Six pôles, vingt-deux thématiques, 16 coordinations pourvues</a:t>
+              <a:t>Six piliers, vingt-deux thématiques, 16 coordinations pourvues</a:t>
             </a:r>
             <a:endParaRPr lang="en-US" sz="3400" dirty="0"/>
           </a:p>
@@ -10918,7 +10918,7 @@
                 <a:ea typeface="DM Sans" pitchFamily="34" charset="-122"/>
                 <a:cs typeface="DM Sans" pitchFamily="34" charset="-120"/>
               </a:rPr>
-              <a:t>Mémoire, culture &amp; patrimoine</a:t>
+              <a:t>Culture, patrimoine et transmission</a:t>
             </a:r>
             <a:endParaRPr lang="en-US" sz="1050" dirty="0"/>
           </a:p>
@@ -10989,7 +10989,7 @@
                 <a:ea typeface="DM Sans" pitchFamily="34" charset="-122"/>
                 <a:cs typeface="DM Sans" pitchFamily="34" charset="-120"/>
               </a:rPr>
-              <a:t>Mémoire &amp; héritage — Félix Mbété Nangmbatnan</a:t>
+              <a:t>Patrimoine historique et archives — Félix Mbété Nangmbatnan</a:t>
             </a:r>
             <a:endParaRPr lang="en-US" sz="950" dirty="0"/>
           </a:p>
@@ -11013,7 +11013,186 @@
                 <a:ea typeface="DM Sans" pitchFamily="34" charset="-122"/>
                 <a:cs typeface="DM Sans" pitchFamily="34" charset="-120"/>
               </a:rPr>
-              <a:t>Culture &amp; patrimoine vivant — Dr Yaphete Madjiradé</a:t>
+              <a:t>Culture et patrimoine immatériel — Dr Yaphete Madjiradé</a:t>
+            </a:r>
+            <a:endParaRPr lang="en-US" sz="950" dirty="0"/>
+          </a:p>
+        </p:txBody>
+      </p:sp>
+      <p:sp>
+        <p:nvSpPr>
+          <p:cNvPr id="9" name="Shape 7"/>
+          <p:cNvSpPr/>
+          <p:nvPr/>
+        </p:nvSpPr>
+        <p:spPr>
+          <a:xfrm>
+            <a:off x="2443429" y="1737360"/>
+            <a:ext cx="1620469" cy="4206240"/>
+          </a:xfrm>
+          <a:prstGeom prst="roundRect">
+            <a:avLst>
+              <a:gd name="adj" fmla="val 9028"/>
+            </a:avLst>
+          </a:prstGeom>
+          <a:solidFill>
+            <a:srgbClr val="F4F6F1"/>
+          </a:solidFill>
+          <a:ln w="9525">
+            <a:solidFill>
+              <a:srgbClr val="D5DDD6"/>
+            </a:solidFill>
+            <a:prstDash val="solid"/>
+          </a:ln>
+        </p:spPr>
+      </p:sp>
+      <p:sp>
+        <p:nvSpPr>
+          <p:cNvPr id="10" name="Shape 8"/>
+          <p:cNvSpPr/>
+          <p:nvPr/>
+        </p:nvSpPr>
+        <p:spPr>
+          <a:xfrm>
+            <a:off x="2717749" y="2011680"/>
+            <a:ext cx="457200" cy="457200"/>
+          </a:xfrm>
+          <a:prstGeom prst="ellipse">
+            <a:avLst/>
+          </a:prstGeom>
+          <a:solidFill>
+            <a:srgbClr val="B6CF45"/>
+          </a:solidFill>
+          <a:ln w="12700">
+            <a:solidFill>
+              <a:srgbClr val="B6CF45"/>
+            </a:solidFill>
+            <a:prstDash val="solid"/>
+          </a:ln>
+        </p:spPr>
+      </p:sp>
+      <p:sp>
+        <p:nvSpPr>
+          <p:cNvPr id="11" name="Text 9"/>
+          <p:cNvSpPr txBox="1"/>
+          <p:nvPr/>
+        </p:nvSpPr>
+        <p:spPr>
+          <a:xfrm>
+            <a:off x="2717749" y="2011680"/>
+            <a:ext cx="457200" cy="457200"/>
+          </a:xfrm>
+          <a:prstGeom prst="rect">
+            <a:avLst/>
+          </a:prstGeom>
+          <a:noFill/>
+          <a:ln/>
+        </p:spPr>
+        <p:txBody>
+          <a:bodyPr wrap="square" lIns="0" tIns="0" rIns="0" bIns="0" rtlCol="0" anchor="ctr"/>
+          <a:lstStyle/>
+          <a:p>
+            <a:pPr algn="ctr" indent="0" marL="0">
+              <a:buNone/>
+            </a:pPr>
+            <a:r>
+              <a:rPr lang="en-US" sz="1200" b="1" dirty="0">
+                <a:solidFill>
+                  <a:srgbClr val="173B2D"/>
+                </a:solidFill>
+                <a:latin typeface="DM Sans" pitchFamily="34" charset="0"/>
+                <a:ea typeface="DM Sans" pitchFamily="34" charset="-122"/>
+                <a:cs typeface="DM Sans" pitchFamily="34" charset="-120"/>
+              </a:rPr>
+              <a:t>II</a:t>
+            </a:r>
+            <a:endParaRPr lang="en-US" sz="1200" dirty="0"/>
+          </a:p>
+        </p:txBody>
+      </p:sp>
+      <p:sp>
+        <p:nvSpPr>
+          <p:cNvPr id="12" name="Text 10"/>
+          <p:cNvSpPr txBox="1"/>
+          <p:nvPr/>
+        </p:nvSpPr>
+        <p:spPr>
+          <a:xfrm>
+            <a:off x="3312109" y="1984248"/>
+            <a:ext cx="568909" cy="548640"/>
+          </a:xfrm>
+          <a:prstGeom prst="rect">
+            <a:avLst/>
+          </a:prstGeom>
+          <a:noFill/>
+          <a:ln/>
+        </p:spPr>
+        <p:txBody>
+          <a:bodyPr wrap="square" lIns="0" tIns="0" rIns="0" bIns="0" rtlCol="0" anchor="ctr">
+            <a:normAutofit/>
+          </a:bodyPr>
+          <a:lstStyle/>
+          <a:p>
+            <a:pPr indent="0" marL="0">
+              <a:buNone/>
+            </a:pPr>
+            <a:r>
+              <a:rPr lang="en-US" sz="1050" b="1" dirty="0">
+                <a:solidFill>
+                  <a:srgbClr val="173B2D"/>
+                </a:solidFill>
+                <a:latin typeface="DM Sans" pitchFamily="34" charset="0"/>
+                <a:ea typeface="DM Sans" pitchFamily="34" charset="-122"/>
+                <a:cs typeface="DM Sans" pitchFamily="34" charset="-120"/>
+              </a:rPr>
+              <a:t>Capital humain et inclusion sociale</a:t>
+            </a:r>
+            <a:endParaRPr lang="en-US" sz="1050" dirty="0"/>
+          </a:p>
+        </p:txBody>
+      </p:sp>
+      <p:sp>
+        <p:nvSpPr>
+          <p:cNvPr id="13" name="Text 11"/>
+          <p:cNvSpPr txBox="1"/>
+          <p:nvPr/>
+        </p:nvSpPr>
+        <p:spPr>
+          <a:xfrm>
+            <a:off x="2717749" y="2697480"/>
+            <a:ext cx="1071829" cy="2971800"/>
+          </a:xfrm>
+          <a:prstGeom prst="rect">
+            <a:avLst/>
+          </a:prstGeom>
+          <a:noFill/>
+          <a:ln/>
+        </p:spPr>
+        <p:txBody>
+          <a:bodyPr wrap="square" lIns="0" tIns="0" rIns="0" bIns="0" rtlCol="0" anchor="t">
+            <a:normAutofit/>
+          </a:bodyPr>
+          <a:lstStyle/>
+          <a:p>
+            <a:pPr indent="0" marL="0">
+              <a:lnSpc>
+                <a:spcPct val="110000"/>
+              </a:lnSpc>
+              <a:spcAft>
+                <a:spcPts val="800"/>
+              </a:spcAft>
+              <a:buNone/>
+            </a:pPr>
+            <a:r>
+              <a:rPr lang="en-US" sz="950" dirty="0">
+                <a:solidFill>
+                  <a:srgbClr val="10241E"/>
+                </a:solidFill>
+                <a:latin typeface="DM Sans" pitchFamily="34" charset="0"/>
+                <a:ea typeface="DM Sans" pitchFamily="34" charset="-122"/>
+                <a:cs typeface="DM Sans" pitchFamily="34" charset="-120"/>
+              </a:rPr>
+              <a:t>Vice-présidence : Franco Joseph Ngarlena.</a:t>
             </a:r>
             <a:endParaRPr lang="en-US" sz="950" dirty="0"/>
           </a:p>
@@ -11037,21 +11216,165 @@
                 <a:ea typeface="DM Sans" pitchFamily="34" charset="-122"/>
                 <a:cs typeface="DM Sans" pitchFamily="34" charset="-120"/>
               </a:rPr>
-              <a:t>Recherche &amp; savoirs — Sylvain Nomaye, ingénieur de conception en informatique</a:t>
+              <a:t>Recherche et enseignement supérieur — Sylvain Nomaye, ingénieur de conception en informatique</a:t>
             </a:r>
             <a:endParaRPr lang="en-US" sz="950" dirty="0"/>
           </a:p>
-        </p:txBody>
-      </p:sp>
-      <p:sp>
-        <p:nvSpPr>
-          <p:cNvPr id="9" name="Shape 7"/>
+          <a:p>
+            <a:pPr marL="177800" indent="-177800">
+              <a:lnSpc>
+                <a:spcPct val="110000"/>
+              </a:lnSpc>
+              <a:spcAft>
+                <a:spcPts val="600"/>
+              </a:spcAft>
+              <a:buSzPct val="100000"/>
+              <a:buChar char="•"/>
+            </a:pPr>
+            <a:r>
+              <a:rPr lang="en-US" sz="950" dirty="0">
+                <a:solidFill>
+                  <a:srgbClr val="10241E"/>
+                </a:solidFill>
+                <a:latin typeface="DM Sans" pitchFamily="34" charset="0"/>
+                <a:ea typeface="DM Sans" pitchFamily="34" charset="-122"/>
+                <a:cs typeface="DM Sans" pitchFamily="34" charset="-120"/>
+              </a:rPr>
+              <a:t>Éducation et formation professionnelle — Bruno Kodjadoum NGARTEL</a:t>
+            </a:r>
+            <a:endParaRPr lang="en-US" sz="950" dirty="0"/>
+          </a:p>
+          <a:p>
+            <a:pPr marL="177800" indent="-177800">
+              <a:lnSpc>
+                <a:spcPct val="110000"/>
+              </a:lnSpc>
+              <a:spcAft>
+                <a:spcPts val="600"/>
+              </a:spcAft>
+              <a:buSzPct val="100000"/>
+              <a:buChar char="•"/>
+            </a:pPr>
+            <a:r>
+              <a:rPr lang="en-US" sz="950" dirty="0">
+                <a:solidFill>
+                  <a:srgbClr val="10241E"/>
+                </a:solidFill>
+                <a:latin typeface="DM Sans" pitchFamily="34" charset="0"/>
+                <a:ea typeface="DM Sans" pitchFamily="34" charset="-122"/>
+                <a:cs typeface="DM Sans" pitchFamily="34" charset="-120"/>
+              </a:rPr>
+              <a:t>Égalité des genres et autonomisation des femmes — Odette Tolmbaye</a:t>
+            </a:r>
+            <a:endParaRPr lang="en-US" sz="950" dirty="0"/>
+          </a:p>
+          <a:p>
+            <a:pPr marL="177800" indent="-177800">
+              <a:lnSpc>
+                <a:spcPct val="110000"/>
+              </a:lnSpc>
+              <a:spcAft>
+                <a:spcPts val="600"/>
+              </a:spcAft>
+              <a:buSzPct val="100000"/>
+              <a:buChar char="•"/>
+            </a:pPr>
+            <a:r>
+              <a:rPr lang="en-US" sz="950" dirty="0">
+                <a:solidFill>
+                  <a:srgbClr val="10241E"/>
+                </a:solidFill>
+                <a:latin typeface="DM Sans" pitchFamily="34" charset="0"/>
+                <a:ea typeface="DM Sans" pitchFamily="34" charset="-122"/>
+                <a:cs typeface="DM Sans" pitchFamily="34" charset="-120"/>
+              </a:rPr>
+              <a:t>Santé et nutrition — Dr Nestor Alladoumdjim</a:t>
+            </a:r>
+            <a:endParaRPr lang="en-US" sz="950" dirty="0"/>
+          </a:p>
+          <a:p>
+            <a:pPr marL="177800" indent="-177800">
+              <a:lnSpc>
+                <a:spcPct val="110000"/>
+              </a:lnSpc>
+              <a:spcAft>
+                <a:spcPts val="600"/>
+              </a:spcAft>
+              <a:buSzPct val="100000"/>
+              <a:buChar char="•"/>
+            </a:pPr>
+            <a:r>
+              <a:rPr lang="en-US" sz="950" dirty="0">
+                <a:solidFill>
+                  <a:srgbClr val="10241E"/>
+                </a:solidFill>
+                <a:latin typeface="DM Sans" pitchFamily="34" charset="0"/>
+                <a:ea typeface="DM Sans" pitchFamily="34" charset="-122"/>
+                <a:cs typeface="DM Sans" pitchFamily="34" charset="-120"/>
+              </a:rPr>
+              <a:t>Protection et inclusion sociale — Solkem Ngarmbatina</a:t>
+            </a:r>
+            <a:endParaRPr lang="en-US" sz="950" dirty="0"/>
+          </a:p>
+          <a:p>
+            <a:pPr marL="177800" indent="-177800">
+              <a:lnSpc>
+                <a:spcPct val="110000"/>
+              </a:lnSpc>
+              <a:spcAft>
+                <a:spcPts val="600"/>
+              </a:spcAft>
+              <a:buSzPct val="100000"/>
+              <a:buChar char="•"/>
+            </a:pPr>
+            <a:r>
+              <a:rPr lang="en-US" sz="950" dirty="0">
+                <a:solidFill>
+                  <a:srgbClr val="10241E"/>
+                </a:solidFill>
+                <a:latin typeface="DM Sans" pitchFamily="34" charset="0"/>
+                <a:ea typeface="DM Sans" pitchFamily="34" charset="-122"/>
+                <a:cs typeface="DM Sans" pitchFamily="34" charset="-120"/>
+              </a:rPr>
+              <a:t>Sport, culture et loisirs — à pourvoir</a:t>
+            </a:r>
+            <a:endParaRPr lang="en-US" sz="950" dirty="0"/>
+          </a:p>
+          <a:p>
+            <a:pPr marL="177800" indent="-177800">
+              <a:lnSpc>
+                <a:spcPct val="110000"/>
+              </a:lnSpc>
+              <a:spcAft>
+                <a:spcPts val="600"/>
+              </a:spcAft>
+              <a:buSzPct val="100000"/>
+              <a:buChar char="•"/>
+            </a:pPr>
+            <a:r>
+              <a:rPr lang="en-US" sz="950" dirty="0">
+                <a:solidFill>
+                  <a:srgbClr val="10241E"/>
+                </a:solidFill>
+                <a:latin typeface="DM Sans" pitchFamily="34" charset="0"/>
+                <a:ea typeface="DM Sans" pitchFamily="34" charset="-122"/>
+                <a:cs typeface="DM Sans" pitchFamily="34" charset="-120"/>
+              </a:rPr>
+              <a:t>Compétences numériques et emploi des jeunes — Rosine Mbaïnodoum</a:t>
+            </a:r>
+            <a:endParaRPr lang="en-US" sz="950" dirty="0"/>
+          </a:p>
+        </p:txBody>
+      </p:sp>
+      <p:sp>
+        <p:nvSpPr>
+          <p:cNvPr id="14" name="Shape 12"/>
           <p:cNvSpPr/>
           <p:nvPr/>
         </p:nvSpPr>
         <p:spPr>
           <a:xfrm>
-            <a:off x="2443429" y="1737360"/>
+            <a:off x="4338218" y="1737360"/>
             <a:ext cx="1620469" cy="4206240"/>
           </a:xfrm>
           <a:prstGeom prst="roundRect">
@@ -11072,13 +11395,13 @@
       </p:sp>
       <p:sp>
         <p:nvSpPr>
-          <p:cNvPr id="10" name="Shape 8"/>
+          <p:cNvPr id="15" name="Shape 13"/>
           <p:cNvSpPr/>
           <p:nvPr/>
         </p:nvSpPr>
         <p:spPr>
           <a:xfrm>
-            <a:off x="2717749" y="2011680"/>
+            <a:off x="4612538" y="2011680"/>
             <a:ext cx="457200" cy="457200"/>
           </a:xfrm>
           <a:prstGeom prst="ellipse">
@@ -11097,13 +11420,13 @@
       </p:sp>
       <p:sp>
         <p:nvSpPr>
-          <p:cNvPr id="11" name="Text 9"/>
-          <p:cNvSpPr txBox="1"/>
-          <p:nvPr/>
-        </p:nvSpPr>
-        <p:spPr>
-          <a:xfrm>
-            <a:off x="2717749" y="2011680"/>
+          <p:cNvPr id="16" name="Text 14"/>
+          <p:cNvSpPr txBox="1"/>
+          <p:nvPr/>
+        </p:nvSpPr>
+        <p:spPr>
+          <a:xfrm>
+            <a:off x="4612538" y="2011680"/>
             <a:ext cx="457200" cy="457200"/>
           </a:xfrm>
           <a:prstGeom prst="rect">
@@ -11128,7 +11451,7 @@
                 <a:ea typeface="DM Sans" pitchFamily="34" charset="-122"/>
                 <a:cs typeface="DM Sans" pitchFamily="34" charset="-120"/>
               </a:rPr>
-              <a:t>II</a:t>
+              <a:t>III</a:t>
             </a:r>
             <a:endParaRPr lang="en-US" sz="1200" dirty="0"/>
           </a:p>
@@ -11136,13 +11459,13 @@
       </p:sp>
       <p:sp>
         <p:nvSpPr>
-          <p:cNvPr id="12" name="Text 10"/>
-          <p:cNvSpPr txBox="1"/>
-          <p:nvPr/>
-        </p:nvSpPr>
-        <p:spPr>
-          <a:xfrm>
-            <a:off x="3312109" y="1984248"/>
+          <p:cNvPr id="17" name="Text 15"/>
+          <p:cNvSpPr txBox="1"/>
+          <p:nvPr/>
+        </p:nvSpPr>
+        <p:spPr>
+          <a:xfrm>
+            <a:off x="5206898" y="1984248"/>
             <a:ext cx="568909" cy="548640"/>
           </a:xfrm>
           <a:prstGeom prst="rect">
@@ -11169,7 +11492,7 @@
                 <a:ea typeface="DM Sans" pitchFamily="34" charset="-122"/>
                 <a:cs typeface="DM Sans" pitchFamily="34" charset="-120"/>
               </a:rPr>
-              <a:t>Services essentiels</a:t>
+              <a:t>Services essentiels et développement territorial</a:t>
             </a:r>
             <a:endParaRPr lang="en-US" sz="1050" dirty="0"/>
           </a:p>
@@ -11177,13 +11500,13 @@
       </p:sp>
       <p:sp>
         <p:nvSpPr>
-          <p:cNvPr id="13" name="Text 11"/>
-          <p:cNvSpPr txBox="1"/>
-          <p:nvPr/>
-        </p:nvSpPr>
-        <p:spPr>
-          <a:xfrm>
-            <a:off x="2717749" y="2697480"/>
+          <p:cNvPr id="18" name="Text 16"/>
+          <p:cNvSpPr txBox="1"/>
+          <p:nvPr/>
+        </p:nvSpPr>
+        <p:spPr>
+          <a:xfrm>
+            <a:off x="4612538" y="2697480"/>
             <a:ext cx="1071829" cy="2971800"/>
           </a:xfrm>
           <a:prstGeom prst="rect">
@@ -11216,7 +11539,7 @@
                 <a:ea typeface="DM Sans" pitchFamily="34" charset="-122"/>
                 <a:cs typeface="DM Sans" pitchFamily="34" charset="-120"/>
               </a:rPr>
-              <a:t>Vice-présidence : Franco Joseph Ngarlena.</a:t>
+              <a:t>Vice-présidence : à pourvoir, par élection.</a:t>
             </a:r>
             <a:endParaRPr lang="en-US" sz="950" dirty="0"/>
           </a:p>
@@ -11240,7 +11563,7 @@
                 <a:ea typeface="DM Sans" pitchFamily="34" charset="-122"/>
                 <a:cs typeface="DM Sans" pitchFamily="34" charset="-120"/>
               </a:rPr>
-              <a:t>Eau, assainissement &amp; hygiène — à pourvoir</a:t>
+              <a:t>Eau, assainissement et hygiène (WASH) — à pourvoir</a:t>
             </a:r>
             <a:endParaRPr lang="en-US" sz="950" dirty="0"/>
           </a:p>
@@ -11264,7 +11587,7 @@
                 <a:ea typeface="DM Sans" pitchFamily="34" charset="-122"/>
                 <a:cs typeface="DM Sans" pitchFamily="34" charset="-120"/>
               </a:rPr>
-              <a:t>Éducation, jeunesse &amp; formation — Bruno Kodjadoum NGARTEL</a:t>
+              <a:t>Transport et développement urbain — à pourvoir</a:t>
             </a:r>
             <a:endParaRPr lang="en-US" sz="950" dirty="0"/>
           </a:p>
@@ -11288,7 +11611,7 @@
                 <a:ea typeface="DM Sans" pitchFamily="34" charset="-122"/>
                 <a:cs typeface="DM Sans" pitchFamily="34" charset="-120"/>
               </a:rPr>
-              <a:t>Genre &amp; autonomisation des femmes — Odette Tolmbaye</a:t>
+              <a:t>Énergie durable — à pourvoir</a:t>
             </a:r>
             <a:endParaRPr lang="en-US" sz="950" dirty="0"/>
           </a:p>
@@ -11312,7 +11635,186 @@
                 <a:ea typeface="DM Sans" pitchFamily="34" charset="-122"/>
                 <a:cs typeface="DM Sans" pitchFamily="34" charset="-120"/>
               </a:rPr>
-              <a:t>Santé, nutrition &amp; prévention — Dr Nestor Alladoumdjim</a:t>
+              <a:t>TIC et connectivité — Bignéro Moïalbéi LE MADANG</a:t>
+            </a:r>
+            <a:endParaRPr lang="en-US" sz="950" dirty="0"/>
+          </a:p>
+        </p:txBody>
+      </p:sp>
+      <p:sp>
+        <p:nvSpPr>
+          <p:cNvPr id="19" name="Shape 17"/>
+          <p:cNvSpPr/>
+          <p:nvPr/>
+        </p:nvSpPr>
+        <p:spPr>
+          <a:xfrm>
+            <a:off x="6233008" y="1737360"/>
+            <a:ext cx="1620469" cy="4206240"/>
+          </a:xfrm>
+          <a:prstGeom prst="roundRect">
+            <a:avLst>
+              <a:gd name="adj" fmla="val 9028"/>
+            </a:avLst>
+          </a:prstGeom>
+          <a:solidFill>
+            <a:srgbClr val="F4F6F1"/>
+          </a:solidFill>
+          <a:ln w="9525">
+            <a:solidFill>
+              <a:srgbClr val="D5DDD6"/>
+            </a:solidFill>
+            <a:prstDash val="solid"/>
+          </a:ln>
+        </p:spPr>
+      </p:sp>
+      <p:sp>
+        <p:nvSpPr>
+          <p:cNvPr id="20" name="Shape 18"/>
+          <p:cNvSpPr/>
+          <p:nvPr/>
+        </p:nvSpPr>
+        <p:spPr>
+          <a:xfrm>
+            <a:off x="6507328" y="2011680"/>
+            <a:ext cx="457200" cy="457200"/>
+          </a:xfrm>
+          <a:prstGeom prst="ellipse">
+            <a:avLst/>
+          </a:prstGeom>
+          <a:solidFill>
+            <a:srgbClr val="B6CF45"/>
+          </a:solidFill>
+          <a:ln w="12700">
+            <a:solidFill>
+              <a:srgbClr val="B6CF45"/>
+            </a:solidFill>
+            <a:prstDash val="solid"/>
+          </a:ln>
+        </p:spPr>
+      </p:sp>
+      <p:sp>
+        <p:nvSpPr>
+          <p:cNvPr id="21" name="Text 19"/>
+          <p:cNvSpPr txBox="1"/>
+          <p:nvPr/>
+        </p:nvSpPr>
+        <p:spPr>
+          <a:xfrm>
+            <a:off x="6507328" y="2011680"/>
+            <a:ext cx="457200" cy="457200"/>
+          </a:xfrm>
+          <a:prstGeom prst="rect">
+            <a:avLst/>
+          </a:prstGeom>
+          <a:noFill/>
+          <a:ln/>
+        </p:spPr>
+        <p:txBody>
+          <a:bodyPr wrap="square" lIns="0" tIns="0" rIns="0" bIns="0" rtlCol="0" anchor="ctr"/>
+          <a:lstStyle/>
+          <a:p>
+            <a:pPr algn="ctr" indent="0" marL="0">
+              <a:buNone/>
+            </a:pPr>
+            <a:r>
+              <a:rPr lang="en-US" sz="1200" b="1" dirty="0">
+                <a:solidFill>
+                  <a:srgbClr val="173B2D"/>
+                </a:solidFill>
+                <a:latin typeface="DM Sans" pitchFamily="34" charset="0"/>
+                <a:ea typeface="DM Sans" pitchFamily="34" charset="-122"/>
+                <a:cs typeface="DM Sans" pitchFamily="34" charset="-120"/>
+              </a:rPr>
+              <a:t>IV</a:t>
+            </a:r>
+            <a:endParaRPr lang="en-US" sz="1200" dirty="0"/>
+          </a:p>
+        </p:txBody>
+      </p:sp>
+      <p:sp>
+        <p:nvSpPr>
+          <p:cNvPr id="22" name="Text 20"/>
+          <p:cNvSpPr txBox="1"/>
+          <p:nvPr/>
+        </p:nvSpPr>
+        <p:spPr>
+          <a:xfrm>
+            <a:off x="7101688" y="1984248"/>
+            <a:ext cx="568909" cy="548640"/>
+          </a:xfrm>
+          <a:prstGeom prst="rect">
+            <a:avLst/>
+          </a:prstGeom>
+          <a:noFill/>
+          <a:ln/>
+        </p:spPr>
+        <p:txBody>
+          <a:bodyPr wrap="square" lIns="0" tIns="0" rIns="0" bIns="0" rtlCol="0" anchor="ctr">
+            <a:normAutofit/>
+          </a:bodyPr>
+          <a:lstStyle/>
+          <a:p>
+            <a:pPr indent="0" marL="0">
+              <a:buNone/>
+            </a:pPr>
+            <a:r>
+              <a:rPr lang="en-US" sz="1050" b="1" dirty="0">
+                <a:solidFill>
+                  <a:srgbClr val="173B2D"/>
+                </a:solidFill>
+                <a:latin typeface="DM Sans" pitchFamily="34" charset="0"/>
+                <a:ea typeface="DM Sans" pitchFamily="34" charset="-122"/>
+                <a:cs typeface="DM Sans" pitchFamily="34" charset="-120"/>
+              </a:rPr>
+              <a:t>Économie inclusive et prospérité locale</a:t>
+            </a:r>
+            <a:endParaRPr lang="en-US" sz="1050" dirty="0"/>
+          </a:p>
+        </p:txBody>
+      </p:sp>
+      <p:sp>
+        <p:nvSpPr>
+          <p:cNvPr id="23" name="Text 21"/>
+          <p:cNvSpPr txBox="1"/>
+          <p:nvPr/>
+        </p:nvSpPr>
+        <p:spPr>
+          <a:xfrm>
+            <a:off x="6507328" y="2697480"/>
+            <a:ext cx="1071829" cy="2971800"/>
+          </a:xfrm>
+          <a:prstGeom prst="rect">
+            <a:avLst/>
+          </a:prstGeom>
+          <a:noFill/>
+          <a:ln/>
+        </p:spPr>
+        <p:txBody>
+          <a:bodyPr wrap="square" lIns="0" tIns="0" rIns="0" bIns="0" rtlCol="0" anchor="t">
+            <a:normAutofit/>
+          </a:bodyPr>
+          <a:lstStyle/>
+          <a:p>
+            <a:pPr indent="0" marL="0">
+              <a:lnSpc>
+                <a:spcPct val="110000"/>
+              </a:lnSpc>
+              <a:spcAft>
+                <a:spcPts val="800"/>
+              </a:spcAft>
+              <a:buNone/>
+            </a:pPr>
+            <a:r>
+              <a:rPr lang="en-US" sz="950" dirty="0">
+                <a:solidFill>
+                  <a:srgbClr val="10241E"/>
+                </a:solidFill>
+                <a:latin typeface="DM Sans" pitchFamily="34" charset="0"/>
+                <a:ea typeface="DM Sans" pitchFamily="34" charset="-122"/>
+                <a:cs typeface="DM Sans" pitchFamily="34" charset="-120"/>
+              </a:rPr>
+              <a:t>Vice-présidence : à pourvoir, par élection.</a:t>
             </a:r>
             <a:endParaRPr lang="en-US" sz="950" dirty="0"/>
           </a:p>
@@ -11336,7 +11838,7 @@
                 <a:ea typeface="DM Sans" pitchFamily="34" charset="-122"/>
                 <a:cs typeface="DM Sans" pitchFamily="34" charset="-120"/>
               </a:rPr>
-              <a:t>Protection sociale, enfance &amp; inclusion — Solkem Ngarmbatina</a:t>
+              <a:t>Agriculture, élevage et sécurité alimentaire — Olivier Allaramadji Nomaye, ingénieur agroéconomiste</a:t>
             </a:r>
             <a:endParaRPr lang="en-US" sz="950" dirty="0"/>
           </a:p>
@@ -11360,7 +11862,7 @@
                 <a:ea typeface="DM Sans" pitchFamily="34" charset="-122"/>
                 <a:cs typeface="DM Sans" pitchFamily="34" charset="-120"/>
               </a:rPr>
-              <a:t>Sport, arts &amp; loisirs — à pourvoir</a:t>
+              <a:t>Moyens d’existence et inclusion financière — Tamar Neloum DOUMANBE</a:t>
             </a:r>
             <a:endParaRPr lang="en-US" sz="950" dirty="0"/>
           </a:p>
@@ -11368,13 +11870,13 @@
       </p:sp>
       <p:sp>
         <p:nvSpPr>
-          <p:cNvPr id="14" name="Shape 12"/>
+          <p:cNvPr id="24" name="Shape 22"/>
           <p:cNvSpPr/>
           <p:nvPr/>
         </p:nvSpPr>
         <p:spPr>
           <a:xfrm>
-            <a:off x="4338218" y="1737360"/>
+            <a:off x="8127797" y="1737360"/>
             <a:ext cx="1620469" cy="4206240"/>
           </a:xfrm>
           <a:prstGeom prst="roundRect">
@@ -11395,13 +11897,13 @@
       </p:sp>
       <p:sp>
         <p:nvSpPr>
-          <p:cNvPr id="15" name="Shape 13"/>
+          <p:cNvPr id="25" name="Shape 23"/>
           <p:cNvSpPr/>
           <p:nvPr/>
         </p:nvSpPr>
         <p:spPr>
           <a:xfrm>
-            <a:off x="4612538" y="2011680"/>
+            <a:off x="8402117" y="2011680"/>
             <a:ext cx="457200" cy="457200"/>
           </a:xfrm>
           <a:prstGeom prst="ellipse">
@@ -11420,13 +11922,13 @@
       </p:sp>
       <p:sp>
         <p:nvSpPr>
-          <p:cNvPr id="16" name="Text 14"/>
-          <p:cNvSpPr txBox="1"/>
-          <p:nvPr/>
-        </p:nvSpPr>
-        <p:spPr>
-          <a:xfrm>
-            <a:off x="4612538" y="2011680"/>
+          <p:cNvPr id="26" name="Text 24"/>
+          <p:cNvSpPr txBox="1"/>
+          <p:nvPr/>
+        </p:nvSpPr>
+        <p:spPr>
+          <a:xfrm>
+            <a:off x="8402117" y="2011680"/>
             <a:ext cx="457200" cy="457200"/>
           </a:xfrm>
           <a:prstGeom prst="rect">
@@ -11451,7 +11953,7 @@
                 <a:ea typeface="DM Sans" pitchFamily="34" charset="-122"/>
                 <a:cs typeface="DM Sans" pitchFamily="34" charset="-120"/>
               </a:rPr>
-              <a:t>III</a:t>
+              <a:t>V</a:t>
             </a:r>
             <a:endParaRPr lang="en-US" sz="1200" dirty="0"/>
           </a:p>
@@ -11459,13 +11961,13 @@
       </p:sp>
       <p:sp>
         <p:nvSpPr>
-          <p:cNvPr id="17" name="Text 15"/>
-          <p:cNvSpPr txBox="1"/>
-          <p:nvPr/>
-        </p:nvSpPr>
-        <p:spPr>
-          <a:xfrm>
-            <a:off x="5206898" y="1984248"/>
+          <p:cNvPr id="27" name="Text 25"/>
+          <p:cNvSpPr txBox="1"/>
+          <p:nvPr/>
+        </p:nvSpPr>
+        <p:spPr>
+          <a:xfrm>
+            <a:off x="8996477" y="1984248"/>
             <a:ext cx="568909" cy="548640"/>
           </a:xfrm>
           <a:prstGeom prst="rect">
@@ -11492,7 +11994,7 @@
                 <a:ea typeface="DM Sans" pitchFamily="34" charset="-122"/>
                 <a:cs typeface="DM Sans" pitchFamily="34" charset="-120"/>
               </a:rPr>
-              <a:t>Gouvernance, paix &amp; plaidoyer</a:t>
+              <a:t>Environnement, climat et résilience</a:t>
             </a:r>
             <a:endParaRPr lang="en-US" sz="1050" dirty="0"/>
           </a:p>
@@ -11500,13 +12002,13 @@
       </p:sp>
       <p:sp>
         <p:nvSpPr>
-          <p:cNvPr id="18" name="Text 16"/>
-          <p:cNvSpPr txBox="1"/>
-          <p:nvPr/>
-        </p:nvSpPr>
-        <p:spPr>
-          <a:xfrm>
-            <a:off x="4612538" y="2697480"/>
+          <p:cNvPr id="28" name="Text 26"/>
+          <p:cNvSpPr txBox="1"/>
+          <p:nvPr/>
+        </p:nvSpPr>
+        <p:spPr>
+          <a:xfrm>
+            <a:off x="8402117" y="2697480"/>
             <a:ext cx="1071829" cy="2971800"/>
           </a:xfrm>
           <a:prstGeom prst="rect">
@@ -11563,7 +12065,7 @@
                 <a:ea typeface="DM Sans" pitchFamily="34" charset="-122"/>
                 <a:cs typeface="DM Sans" pitchFamily="34" charset="-120"/>
               </a:rPr>
-              <a:t>Gouvernance &amp; plaidoyer — Adoumbé Maoura, président de l’association</a:t>
+              <a:t>Environnement, climat et ressources naturelles — à pourvoir</a:t>
             </a:r>
             <a:endParaRPr lang="en-US" sz="950" dirty="0"/>
           </a:p>
@@ -11587,7 +12089,186 @@
                 <a:ea typeface="DM Sans" pitchFamily="34" charset="-122"/>
                 <a:cs typeface="DM Sans" pitchFamily="34" charset="-120"/>
               </a:rPr>
-              <a:t>Paix &amp; cohésion — Sa Majesté Moulbe Brahim Nadoumbeye, chef de canton de Bébopen</a:t>
+              <a:t>Réduction des risques de catastrophe et urgences — à pourvoir</a:t>
+            </a:r>
+            <a:endParaRPr lang="en-US" sz="950" dirty="0"/>
+          </a:p>
+        </p:txBody>
+      </p:sp>
+      <p:sp>
+        <p:nvSpPr>
+          <p:cNvPr id="29" name="Shape 27"/>
+          <p:cNvSpPr/>
+          <p:nvPr/>
+        </p:nvSpPr>
+        <p:spPr>
+          <a:xfrm>
+            <a:off x="10022586" y="1737360"/>
+            <a:ext cx="1620469" cy="4206240"/>
+          </a:xfrm>
+          <a:prstGeom prst="roundRect">
+            <a:avLst>
+              <a:gd name="adj" fmla="val 9028"/>
+            </a:avLst>
+          </a:prstGeom>
+          <a:solidFill>
+            <a:srgbClr val="F4F6F1"/>
+          </a:solidFill>
+          <a:ln w="9525">
+            <a:solidFill>
+              <a:srgbClr val="D5DDD6"/>
+            </a:solidFill>
+            <a:prstDash val="solid"/>
+          </a:ln>
+        </p:spPr>
+      </p:sp>
+      <p:sp>
+        <p:nvSpPr>
+          <p:cNvPr id="30" name="Shape 28"/>
+          <p:cNvSpPr/>
+          <p:nvPr/>
+        </p:nvSpPr>
+        <p:spPr>
+          <a:xfrm>
+            <a:off x="10296906" y="2011680"/>
+            <a:ext cx="457200" cy="457200"/>
+          </a:xfrm>
+          <a:prstGeom prst="ellipse">
+            <a:avLst/>
+          </a:prstGeom>
+          <a:solidFill>
+            <a:srgbClr val="B6CF45"/>
+          </a:solidFill>
+          <a:ln w="12700">
+            <a:solidFill>
+              <a:srgbClr val="B6CF45"/>
+            </a:solidFill>
+            <a:prstDash val="solid"/>
+          </a:ln>
+        </p:spPr>
+      </p:sp>
+      <p:sp>
+        <p:nvSpPr>
+          <p:cNvPr id="31" name="Text 29"/>
+          <p:cNvSpPr txBox="1"/>
+          <p:nvPr/>
+        </p:nvSpPr>
+        <p:spPr>
+          <a:xfrm>
+            <a:off x="10296906" y="2011680"/>
+            <a:ext cx="457200" cy="457200"/>
+          </a:xfrm>
+          <a:prstGeom prst="rect">
+            <a:avLst/>
+          </a:prstGeom>
+          <a:noFill/>
+          <a:ln/>
+        </p:spPr>
+        <p:txBody>
+          <a:bodyPr wrap="square" lIns="0" tIns="0" rIns="0" bIns="0" rtlCol="0" anchor="ctr"/>
+          <a:lstStyle/>
+          <a:p>
+            <a:pPr algn="ctr" indent="0" marL="0">
+              <a:buNone/>
+            </a:pPr>
+            <a:r>
+              <a:rPr lang="en-US" sz="1200" b="1" dirty="0">
+                <a:solidFill>
+                  <a:srgbClr val="173B2D"/>
+                </a:solidFill>
+                <a:latin typeface="DM Sans" pitchFamily="34" charset="0"/>
+                <a:ea typeface="DM Sans" pitchFamily="34" charset="-122"/>
+                <a:cs typeface="DM Sans" pitchFamily="34" charset="-120"/>
+              </a:rPr>
+              <a:t>VI</a:t>
+            </a:r>
+            <a:endParaRPr lang="en-US" sz="1200" dirty="0"/>
+          </a:p>
+        </p:txBody>
+      </p:sp>
+      <p:sp>
+        <p:nvSpPr>
+          <p:cNvPr id="32" name="Text 30"/>
+          <p:cNvSpPr txBox="1"/>
+          <p:nvPr/>
+        </p:nvSpPr>
+        <p:spPr>
+          <a:xfrm>
+            <a:off x="10891266" y="1984248"/>
+            <a:ext cx="568909" cy="548640"/>
+          </a:xfrm>
+          <a:prstGeom prst="rect">
+            <a:avLst/>
+          </a:prstGeom>
+          <a:noFill/>
+          <a:ln/>
+        </p:spPr>
+        <p:txBody>
+          <a:bodyPr wrap="square" lIns="0" tIns="0" rIns="0" bIns="0" rtlCol="0" anchor="ctr">
+            <a:normAutofit/>
+          </a:bodyPr>
+          <a:lstStyle/>
+          <a:p>
+            <a:pPr indent="0" marL="0">
+              <a:buNone/>
+            </a:pPr>
+            <a:r>
+              <a:rPr lang="en-US" sz="1050" b="1" dirty="0">
+                <a:solidFill>
+                  <a:srgbClr val="173B2D"/>
+                </a:solidFill>
+                <a:latin typeface="DM Sans" pitchFamily="34" charset="0"/>
+                <a:ea typeface="DM Sans" pitchFamily="34" charset="-122"/>
+                <a:cs typeface="DM Sans" pitchFamily="34" charset="-120"/>
+              </a:rPr>
+              <a:t>Gouvernance, paix et partenariats</a:t>
+            </a:r>
+            <a:endParaRPr lang="en-US" sz="1050" dirty="0"/>
+          </a:p>
+        </p:txBody>
+      </p:sp>
+      <p:sp>
+        <p:nvSpPr>
+          <p:cNvPr id="33" name="Text 31"/>
+          <p:cNvSpPr txBox="1"/>
+          <p:nvPr/>
+        </p:nvSpPr>
+        <p:spPr>
+          <a:xfrm>
+            <a:off x="10296906" y="2697480"/>
+            <a:ext cx="1071829" cy="2971800"/>
+          </a:xfrm>
+          <a:prstGeom prst="rect">
+            <a:avLst/>
+          </a:prstGeom>
+          <a:noFill/>
+          <a:ln/>
+        </p:spPr>
+        <p:txBody>
+          <a:bodyPr wrap="square" lIns="0" tIns="0" rIns="0" bIns="0" rtlCol="0" anchor="t">
+            <a:normAutofit/>
+          </a:bodyPr>
+          <a:lstStyle/>
+          <a:p>
+            <a:pPr indent="0" marL="0">
+              <a:lnSpc>
+                <a:spcPct val="110000"/>
+              </a:lnSpc>
+              <a:spcAft>
+                <a:spcPts val="800"/>
+              </a:spcAft>
+              <a:buNone/>
+            </a:pPr>
+            <a:r>
+              <a:rPr lang="en-US" sz="950" dirty="0">
+                <a:solidFill>
+                  <a:srgbClr val="10241E"/>
+                </a:solidFill>
+                <a:latin typeface="DM Sans" pitchFamily="34" charset="0"/>
+                <a:ea typeface="DM Sans" pitchFamily="34" charset="-122"/>
+                <a:cs typeface="DM Sans" pitchFamily="34" charset="-120"/>
+              </a:rPr>
+              <a:t>Vice-présidence : à pourvoir, par élection.</a:t>
             </a:r>
             <a:endParaRPr lang="en-US" sz="950" dirty="0"/>
           </a:p>
@@ -11611,7 +12292,7 @@
                 <a:ea typeface="DM Sans" pitchFamily="34" charset="-122"/>
                 <a:cs typeface="DM Sans" pitchFamily="34" charset="-120"/>
               </a:rPr>
-              <a:t>Réseau d’experts &amp; diaspora — Edgard Djerassem Djimhotengar</a:t>
+              <a:t>Gouvernance et société civile — Adoumbé Maoura, président de l’association</a:t>
             </a:r>
             <a:endParaRPr lang="en-US" sz="950" dirty="0"/>
           </a:p>
@@ -11635,186 +12316,7 @@
                 <a:ea typeface="DM Sans" pitchFamily="34" charset="-122"/>
                 <a:cs typeface="DM Sans" pitchFamily="34" charset="-120"/>
               </a:rPr>
-              <a:t>Justice &amp; droits humains — Dr Eugène Ngartebaye Le Yotha</a:t>
-            </a:r>
-            <a:endParaRPr lang="en-US" sz="950" dirty="0"/>
-          </a:p>
-        </p:txBody>
-      </p:sp>
-      <p:sp>
-        <p:nvSpPr>
-          <p:cNvPr id="19" name="Shape 17"/>
-          <p:cNvSpPr/>
-          <p:nvPr/>
-        </p:nvSpPr>
-        <p:spPr>
-          <a:xfrm>
-            <a:off x="6233008" y="1737360"/>
-            <a:ext cx="1620469" cy="4206240"/>
-          </a:xfrm>
-          <a:prstGeom prst="roundRect">
-            <a:avLst>
-              <a:gd name="adj" fmla="val 9028"/>
-            </a:avLst>
-          </a:prstGeom>
-          <a:solidFill>
-            <a:srgbClr val="F4F6F1"/>
-          </a:solidFill>
-          <a:ln w="9525">
-            <a:solidFill>
-              <a:srgbClr val="D5DDD6"/>
-            </a:solidFill>
-            <a:prstDash val="solid"/>
-          </a:ln>
-        </p:spPr>
-      </p:sp>
-      <p:sp>
-        <p:nvSpPr>
-          <p:cNvPr id="20" name="Shape 18"/>
-          <p:cNvSpPr/>
-          <p:nvPr/>
-        </p:nvSpPr>
-        <p:spPr>
-          <a:xfrm>
-            <a:off x="6507328" y="2011680"/>
-            <a:ext cx="457200" cy="457200"/>
-          </a:xfrm>
-          <a:prstGeom prst="ellipse">
-            <a:avLst/>
-          </a:prstGeom>
-          <a:solidFill>
-            <a:srgbClr val="B6CF45"/>
-          </a:solidFill>
-          <a:ln w="12700">
-            <a:solidFill>
-              <a:srgbClr val="B6CF45"/>
-            </a:solidFill>
-            <a:prstDash val="solid"/>
-          </a:ln>
-        </p:spPr>
-      </p:sp>
-      <p:sp>
-        <p:nvSpPr>
-          <p:cNvPr id="21" name="Text 19"/>
-          <p:cNvSpPr txBox="1"/>
-          <p:nvPr/>
-        </p:nvSpPr>
-        <p:spPr>
-          <a:xfrm>
-            <a:off x="6507328" y="2011680"/>
-            <a:ext cx="457200" cy="457200"/>
-          </a:xfrm>
-          <a:prstGeom prst="rect">
-            <a:avLst/>
-          </a:prstGeom>
-          <a:noFill/>
-          <a:ln/>
-        </p:spPr>
-        <p:txBody>
-          <a:bodyPr wrap="square" lIns="0" tIns="0" rIns="0" bIns="0" rtlCol="0" anchor="ctr"/>
-          <a:lstStyle/>
-          <a:p>
-            <a:pPr algn="ctr" indent="0" marL="0">
-              <a:buNone/>
-            </a:pPr>
-            <a:r>
-              <a:rPr lang="en-US" sz="1200" b="1" dirty="0">
-                <a:solidFill>
-                  <a:srgbClr val="173B2D"/>
-                </a:solidFill>
-                <a:latin typeface="DM Sans" pitchFamily="34" charset="0"/>
-                <a:ea typeface="DM Sans" pitchFamily="34" charset="-122"/>
-                <a:cs typeface="DM Sans" pitchFamily="34" charset="-120"/>
-              </a:rPr>
-              <a:t>IV</a:t>
-            </a:r>
-            <a:endParaRPr lang="en-US" sz="1200" dirty="0"/>
-          </a:p>
-        </p:txBody>
-      </p:sp>
-      <p:sp>
-        <p:nvSpPr>
-          <p:cNvPr id="22" name="Text 20"/>
-          <p:cNvSpPr txBox="1"/>
-          <p:nvPr/>
-        </p:nvSpPr>
-        <p:spPr>
-          <a:xfrm>
-            <a:off x="7101688" y="1984248"/>
-            <a:ext cx="568909" cy="548640"/>
-          </a:xfrm>
-          <a:prstGeom prst="rect">
-            <a:avLst/>
-          </a:prstGeom>
-          <a:noFill/>
-          <a:ln/>
-        </p:spPr>
-        <p:txBody>
-          <a:bodyPr wrap="square" lIns="0" tIns="0" rIns="0" bIns="0" rtlCol="0" anchor="ctr">
-            <a:normAutofit/>
-          </a:bodyPr>
-          <a:lstStyle/>
-          <a:p>
-            <a:pPr indent="0" marL="0">
-              <a:buNone/>
-            </a:pPr>
-            <a:r>
-              <a:rPr lang="en-US" sz="1050" b="1" dirty="0">
-                <a:solidFill>
-                  <a:srgbClr val="173B2D"/>
-                </a:solidFill>
-                <a:latin typeface="DM Sans" pitchFamily="34" charset="0"/>
-                <a:ea typeface="DM Sans" pitchFamily="34" charset="-122"/>
-                <a:cs typeface="DM Sans" pitchFamily="34" charset="-120"/>
-              </a:rPr>
-              <a:t>Numérique &amp; innovation</a:t>
-            </a:r>
-            <a:endParaRPr lang="en-US" sz="1050" dirty="0"/>
-          </a:p>
-        </p:txBody>
-      </p:sp>
-      <p:sp>
-        <p:nvSpPr>
-          <p:cNvPr id="23" name="Text 21"/>
-          <p:cNvSpPr txBox="1"/>
-          <p:nvPr/>
-        </p:nvSpPr>
-        <p:spPr>
-          <a:xfrm>
-            <a:off x="6507328" y="2697480"/>
-            <a:ext cx="1071829" cy="2971800"/>
-          </a:xfrm>
-          <a:prstGeom prst="rect">
-            <a:avLst/>
-          </a:prstGeom>
-          <a:noFill/>
-          <a:ln/>
-        </p:spPr>
-        <p:txBody>
-          <a:bodyPr wrap="square" lIns="0" tIns="0" rIns="0" bIns="0" rtlCol="0" anchor="t">
-            <a:normAutofit/>
-          </a:bodyPr>
-          <a:lstStyle/>
-          <a:p>
-            <a:pPr indent="0" marL="0">
-              <a:lnSpc>
-                <a:spcPct val="110000"/>
-              </a:lnSpc>
-              <a:spcAft>
-                <a:spcPts val="800"/>
-              </a:spcAft>
-              <a:buNone/>
-            </a:pPr>
-            <a:r>
-              <a:rPr lang="en-US" sz="950" dirty="0">
-                <a:solidFill>
-                  <a:srgbClr val="10241E"/>
-                </a:solidFill>
-                <a:latin typeface="DM Sans" pitchFamily="34" charset="0"/>
-                <a:ea typeface="DM Sans" pitchFamily="34" charset="-122"/>
-                <a:cs typeface="DM Sans" pitchFamily="34" charset="-120"/>
-              </a:rPr>
-              <a:t>Vice-présidence : à pourvoir, par élection.</a:t>
+              <a:t>Paix et cohésion sociale — Sa Majesté Moulbe Brahim Nadoumbeye, chef de canton de Bébopen</a:t>
             </a:r>
             <a:endParaRPr lang="en-US" sz="950" dirty="0"/>
           </a:p>
@@ -11838,7 +12340,7 @@
                 <a:ea typeface="DM Sans" pitchFamily="34" charset="-122"/>
                 <a:cs typeface="DM Sans" pitchFamily="34" charset="-120"/>
               </a:rPr>
-              <a:t>Connectivité &amp; services numériques — Bignéro Moïalbéi LE MADANG</a:t>
+              <a:t>Diaspora et partenariats — Edgard Djerassem Djimhotengar</a:t>
             </a:r>
             <a:endParaRPr lang="en-US" sz="950" dirty="0"/>
           </a:p>
@@ -11862,7 +12364,7 @@
                 <a:ea typeface="DM Sans" pitchFamily="34" charset="-122"/>
                 <a:cs typeface="DM Sans" pitchFamily="34" charset="-120"/>
               </a:rPr>
-              <a:t>Intelligence artificielle &amp; données — Bonheur Allahaddje</a:t>
+              <a:t>Droits humains et accès à la justice — Dr Eugène Ngartebaye Le Yotha</a:t>
             </a:r>
             <a:endParaRPr lang="en-US" sz="950" dirty="0"/>
           </a:p>
@@ -11886,509 +12388,7 @@
                 <a:ea typeface="DM Sans" pitchFamily="34" charset="-122"/>
                 <a:cs typeface="DM Sans" pitchFamily="34" charset="-120"/>
               </a:rPr>
-              <a:t>Compétences &amp; entrepreneuriat numérique — Rosine Mbaïnodoum</a:t>
-            </a:r>
-            <a:endParaRPr lang="en-US" sz="950" dirty="0"/>
-          </a:p>
-        </p:txBody>
-      </p:sp>
-      <p:sp>
-        <p:nvSpPr>
-          <p:cNvPr id="24" name="Shape 22"/>
-          <p:cNvSpPr/>
-          <p:nvPr/>
-        </p:nvSpPr>
-        <p:spPr>
-          <a:xfrm>
-            <a:off x="8127797" y="1737360"/>
-            <a:ext cx="1620469" cy="4206240"/>
-          </a:xfrm>
-          <a:prstGeom prst="roundRect">
-            <a:avLst>
-              <a:gd name="adj" fmla="val 9028"/>
-            </a:avLst>
-          </a:prstGeom>
-          <a:solidFill>
-            <a:srgbClr val="F4F6F1"/>
-          </a:solidFill>
-          <a:ln w="9525">
-            <a:solidFill>
-              <a:srgbClr val="D5DDD6"/>
-            </a:solidFill>
-            <a:prstDash val="solid"/>
-          </a:ln>
-        </p:spPr>
-      </p:sp>
-      <p:sp>
-        <p:nvSpPr>
-          <p:cNvPr id="25" name="Shape 23"/>
-          <p:cNvSpPr/>
-          <p:nvPr/>
-        </p:nvSpPr>
-        <p:spPr>
-          <a:xfrm>
-            <a:off x="8402117" y="2011680"/>
-            <a:ext cx="457200" cy="457200"/>
-          </a:xfrm>
-          <a:prstGeom prst="ellipse">
-            <a:avLst/>
-          </a:prstGeom>
-          <a:solidFill>
-            <a:srgbClr val="B6CF45"/>
-          </a:solidFill>
-          <a:ln w="12700">
-            <a:solidFill>
-              <a:srgbClr val="B6CF45"/>
-            </a:solidFill>
-            <a:prstDash val="solid"/>
-          </a:ln>
-        </p:spPr>
-      </p:sp>
-      <p:sp>
-        <p:nvSpPr>
-          <p:cNvPr id="26" name="Text 24"/>
-          <p:cNvSpPr txBox="1"/>
-          <p:nvPr/>
-        </p:nvSpPr>
-        <p:spPr>
-          <a:xfrm>
-            <a:off x="8402117" y="2011680"/>
-            <a:ext cx="457200" cy="457200"/>
-          </a:xfrm>
-          <a:prstGeom prst="rect">
-            <a:avLst/>
-          </a:prstGeom>
-          <a:noFill/>
-          <a:ln/>
-        </p:spPr>
-        <p:txBody>
-          <a:bodyPr wrap="square" lIns="0" tIns="0" rIns="0" bIns="0" rtlCol="0" anchor="ctr"/>
-          <a:lstStyle/>
-          <a:p>
-            <a:pPr algn="ctr" indent="0" marL="0">
-              <a:buNone/>
-            </a:pPr>
-            <a:r>
-              <a:rPr lang="en-US" sz="1200" b="1" dirty="0">
-                <a:solidFill>
-                  <a:srgbClr val="173B2D"/>
-                </a:solidFill>
-                <a:latin typeface="DM Sans" pitchFamily="34" charset="0"/>
-                <a:ea typeface="DM Sans" pitchFamily="34" charset="-122"/>
-                <a:cs typeface="DM Sans" pitchFamily="34" charset="-120"/>
-              </a:rPr>
-              <a:t>V</a:t>
-            </a:r>
-            <a:endParaRPr lang="en-US" sz="1200" dirty="0"/>
-          </a:p>
-        </p:txBody>
-      </p:sp>
-      <p:sp>
-        <p:nvSpPr>
-          <p:cNvPr id="27" name="Text 25"/>
-          <p:cNvSpPr txBox="1"/>
-          <p:nvPr/>
-        </p:nvSpPr>
-        <p:spPr>
-          <a:xfrm>
-            <a:off x="8996477" y="1984248"/>
-            <a:ext cx="568909" cy="548640"/>
-          </a:xfrm>
-          <a:prstGeom prst="rect">
-            <a:avLst/>
-          </a:prstGeom>
-          <a:noFill/>
-          <a:ln/>
-        </p:spPr>
-        <p:txBody>
-          <a:bodyPr wrap="square" lIns="0" tIns="0" rIns="0" bIns="0" rtlCol="0" anchor="ctr">
-            <a:normAutofit/>
-          </a:bodyPr>
-          <a:lstStyle/>
-          <a:p>
-            <a:pPr indent="0" marL="0">
-              <a:buNone/>
-            </a:pPr>
-            <a:r>
-              <a:rPr lang="en-US" sz="1050" b="1" dirty="0">
-                <a:solidFill>
-                  <a:srgbClr val="173B2D"/>
-                </a:solidFill>
-                <a:latin typeface="DM Sans" pitchFamily="34" charset="0"/>
-                <a:ea typeface="DM Sans" pitchFamily="34" charset="-122"/>
-                <a:cs typeface="DM Sans" pitchFamily="34" charset="-120"/>
-              </a:rPr>
-              <a:t>Économie &amp; ressources naturelles</a:t>
-            </a:r>
-            <a:endParaRPr lang="en-US" sz="1050" dirty="0"/>
-          </a:p>
-        </p:txBody>
-      </p:sp>
-      <p:sp>
-        <p:nvSpPr>
-          <p:cNvPr id="28" name="Text 26"/>
-          <p:cNvSpPr txBox="1"/>
-          <p:nvPr/>
-        </p:nvSpPr>
-        <p:spPr>
-          <a:xfrm>
-            <a:off x="8402117" y="2697480"/>
-            <a:ext cx="1071829" cy="2971800"/>
-          </a:xfrm>
-          <a:prstGeom prst="rect">
-            <a:avLst/>
-          </a:prstGeom>
-          <a:noFill/>
-          <a:ln/>
-        </p:spPr>
-        <p:txBody>
-          <a:bodyPr wrap="square" lIns="0" tIns="0" rIns="0" bIns="0" rtlCol="0" anchor="t">
-            <a:normAutofit/>
-          </a:bodyPr>
-          <a:lstStyle/>
-          <a:p>
-            <a:pPr indent="0" marL="0">
-              <a:lnSpc>
-                <a:spcPct val="110000"/>
-              </a:lnSpc>
-              <a:spcAft>
-                <a:spcPts val="800"/>
-              </a:spcAft>
-              <a:buNone/>
-            </a:pPr>
-            <a:r>
-              <a:rPr lang="en-US" sz="950" dirty="0">
-                <a:solidFill>
-                  <a:srgbClr val="10241E"/>
-                </a:solidFill>
-                <a:latin typeface="DM Sans" pitchFamily="34" charset="0"/>
-                <a:ea typeface="DM Sans" pitchFamily="34" charset="-122"/>
-                <a:cs typeface="DM Sans" pitchFamily="34" charset="-120"/>
-              </a:rPr>
-              <a:t>Vice-présidence : à pourvoir, par élection.</a:t>
-            </a:r>
-            <a:endParaRPr lang="en-US" sz="950" dirty="0"/>
-          </a:p>
-          <a:p>
-            <a:pPr marL="177800" indent="-177800">
-              <a:lnSpc>
-                <a:spcPct val="110000"/>
-              </a:lnSpc>
-              <a:spcAft>
-                <a:spcPts val="600"/>
-              </a:spcAft>
-              <a:buSzPct val="100000"/>
-              <a:buChar char="•"/>
-            </a:pPr>
-            <a:r>
-              <a:rPr lang="en-US" sz="950" dirty="0">
-                <a:solidFill>
-                  <a:srgbClr val="10241E"/>
-                </a:solidFill>
-                <a:latin typeface="DM Sans" pitchFamily="34" charset="0"/>
-                <a:ea typeface="DM Sans" pitchFamily="34" charset="-122"/>
-                <a:cs typeface="DM Sans" pitchFamily="34" charset="-120"/>
-              </a:rPr>
-              <a:t>Agriculture, élevage &amp; sécurité alimentaire — Olivier Allaramadji Nomaye, ingénieur agroéconomiste</a:t>
-            </a:r>
-            <a:endParaRPr lang="en-US" sz="950" dirty="0"/>
-          </a:p>
-          <a:p>
-            <a:pPr marL="177800" indent="-177800">
-              <a:lnSpc>
-                <a:spcPct val="110000"/>
-              </a:lnSpc>
-              <a:spcAft>
-                <a:spcPts val="600"/>
-              </a:spcAft>
-              <a:buSzPct val="100000"/>
-              <a:buChar char="•"/>
-            </a:pPr>
-            <a:r>
-              <a:rPr lang="en-US" sz="950" dirty="0">
-                <a:solidFill>
-                  <a:srgbClr val="10241E"/>
-                </a:solidFill>
-                <a:latin typeface="DM Sans" pitchFamily="34" charset="0"/>
-                <a:ea typeface="DM Sans" pitchFamily="34" charset="-122"/>
-                <a:cs typeface="DM Sans" pitchFamily="34" charset="-120"/>
-              </a:rPr>
-              <a:t>Entrepreneuriat &amp; finance inclusive — Tamar Neloum DOUMANBE</a:t>
-            </a:r>
-            <a:endParaRPr lang="en-US" sz="950" dirty="0"/>
-          </a:p>
-          <a:p>
-            <a:pPr marL="177800" indent="-177800">
-              <a:lnSpc>
-                <a:spcPct val="110000"/>
-              </a:lnSpc>
-              <a:spcAft>
-                <a:spcPts val="600"/>
-              </a:spcAft>
-              <a:buSzPct val="100000"/>
-              <a:buChar char="•"/>
-            </a:pPr>
-            <a:r>
-              <a:rPr lang="en-US" sz="950" dirty="0">
-                <a:solidFill>
-                  <a:srgbClr val="10241E"/>
-                </a:solidFill>
-                <a:latin typeface="DM Sans" pitchFamily="34" charset="0"/>
-                <a:ea typeface="DM Sans" pitchFamily="34" charset="-122"/>
-                <a:cs typeface="DM Sans" pitchFamily="34" charset="-120"/>
-              </a:rPr>
-              <a:t>Environnement, climat &amp; ressources naturelles — à pourvoir</a:t>
-            </a:r>
-            <a:endParaRPr lang="en-US" sz="950" dirty="0"/>
-          </a:p>
-        </p:txBody>
-      </p:sp>
-      <p:sp>
-        <p:nvSpPr>
-          <p:cNvPr id="29" name="Shape 27"/>
-          <p:cNvSpPr/>
-          <p:nvPr/>
-        </p:nvSpPr>
-        <p:spPr>
-          <a:xfrm>
-            <a:off x="10022586" y="1737360"/>
-            <a:ext cx="1620469" cy="4206240"/>
-          </a:xfrm>
-          <a:prstGeom prst="roundRect">
-            <a:avLst>
-              <a:gd name="adj" fmla="val 9028"/>
-            </a:avLst>
-          </a:prstGeom>
-          <a:solidFill>
-            <a:srgbClr val="F4F6F1"/>
-          </a:solidFill>
-          <a:ln w="9525">
-            <a:solidFill>
-              <a:srgbClr val="D5DDD6"/>
-            </a:solidFill>
-            <a:prstDash val="solid"/>
-          </a:ln>
-        </p:spPr>
-      </p:sp>
-      <p:sp>
-        <p:nvSpPr>
-          <p:cNvPr id="30" name="Shape 28"/>
-          <p:cNvSpPr/>
-          <p:nvPr/>
-        </p:nvSpPr>
-        <p:spPr>
-          <a:xfrm>
-            <a:off x="10296906" y="2011680"/>
-            <a:ext cx="457200" cy="457200"/>
-          </a:xfrm>
-          <a:prstGeom prst="ellipse">
-            <a:avLst/>
-          </a:prstGeom>
-          <a:solidFill>
-            <a:srgbClr val="B6CF45"/>
-          </a:solidFill>
-          <a:ln w="12700">
-            <a:solidFill>
-              <a:srgbClr val="B6CF45"/>
-            </a:solidFill>
-            <a:prstDash val="solid"/>
-          </a:ln>
-        </p:spPr>
-      </p:sp>
-      <p:sp>
-        <p:nvSpPr>
-          <p:cNvPr id="31" name="Text 29"/>
-          <p:cNvSpPr txBox="1"/>
-          <p:nvPr/>
-        </p:nvSpPr>
-        <p:spPr>
-          <a:xfrm>
-            <a:off x="10296906" y="2011680"/>
-            <a:ext cx="457200" cy="457200"/>
-          </a:xfrm>
-          <a:prstGeom prst="rect">
-            <a:avLst/>
-          </a:prstGeom>
-          <a:noFill/>
-          <a:ln/>
-        </p:spPr>
-        <p:txBody>
-          <a:bodyPr wrap="square" lIns="0" tIns="0" rIns="0" bIns="0" rtlCol="0" anchor="ctr"/>
-          <a:lstStyle/>
-          <a:p>
-            <a:pPr algn="ctr" indent="0" marL="0">
-              <a:buNone/>
-            </a:pPr>
-            <a:r>
-              <a:rPr lang="en-US" sz="1200" b="1" dirty="0">
-                <a:solidFill>
-                  <a:srgbClr val="173B2D"/>
-                </a:solidFill>
-                <a:latin typeface="DM Sans" pitchFamily="34" charset="0"/>
-                <a:ea typeface="DM Sans" pitchFamily="34" charset="-122"/>
-                <a:cs typeface="DM Sans" pitchFamily="34" charset="-120"/>
-              </a:rPr>
-              <a:t>VI</a:t>
-            </a:r>
-            <a:endParaRPr lang="en-US" sz="1200" dirty="0"/>
-          </a:p>
-        </p:txBody>
-      </p:sp>
-      <p:sp>
-        <p:nvSpPr>
-          <p:cNvPr id="32" name="Text 30"/>
-          <p:cNvSpPr txBox="1"/>
-          <p:nvPr/>
-        </p:nvSpPr>
-        <p:spPr>
-          <a:xfrm>
-            <a:off x="10891266" y="1984248"/>
-            <a:ext cx="568909" cy="548640"/>
-          </a:xfrm>
-          <a:prstGeom prst="rect">
-            <a:avLst/>
-          </a:prstGeom>
-          <a:noFill/>
-          <a:ln/>
-        </p:spPr>
-        <p:txBody>
-          <a:bodyPr wrap="square" lIns="0" tIns="0" rIns="0" bIns="0" rtlCol="0" anchor="ctr">
-            <a:normAutofit/>
-          </a:bodyPr>
-          <a:lstStyle/>
-          <a:p>
-            <a:pPr indent="0" marL="0">
-              <a:buNone/>
-            </a:pPr>
-            <a:r>
-              <a:rPr lang="en-US" sz="1050" b="1" dirty="0">
-                <a:solidFill>
-                  <a:srgbClr val="173B2D"/>
-                </a:solidFill>
-                <a:latin typeface="DM Sans" pitchFamily="34" charset="0"/>
-                <a:ea typeface="DM Sans" pitchFamily="34" charset="-122"/>
-                <a:cs typeface="DM Sans" pitchFamily="34" charset="-120"/>
-              </a:rPr>
-              <a:t>Infrastructures, territoire &amp; risques</a:t>
-            </a:r>
-            <a:endParaRPr lang="en-US" sz="1050" dirty="0"/>
-          </a:p>
-        </p:txBody>
-      </p:sp>
-      <p:sp>
-        <p:nvSpPr>
-          <p:cNvPr id="33" name="Text 31"/>
-          <p:cNvSpPr txBox="1"/>
-          <p:nvPr/>
-        </p:nvSpPr>
-        <p:spPr>
-          <a:xfrm>
-            <a:off x="10296906" y="2697480"/>
-            <a:ext cx="1071829" cy="2971800"/>
-          </a:xfrm>
-          <a:prstGeom prst="rect">
-            <a:avLst/>
-          </a:prstGeom>
-          <a:noFill/>
-          <a:ln/>
-        </p:spPr>
-        <p:txBody>
-          <a:bodyPr wrap="square" lIns="0" tIns="0" rIns="0" bIns="0" rtlCol="0" anchor="t">
-            <a:normAutofit/>
-          </a:bodyPr>
-          <a:lstStyle/>
-          <a:p>
-            <a:pPr indent="0" marL="0">
-              <a:lnSpc>
-                <a:spcPct val="110000"/>
-              </a:lnSpc>
-              <a:spcAft>
-                <a:spcPts val="800"/>
-              </a:spcAft>
-              <a:buNone/>
-            </a:pPr>
-            <a:r>
-              <a:rPr lang="en-US" sz="950" dirty="0">
-                <a:solidFill>
-                  <a:srgbClr val="10241E"/>
-                </a:solidFill>
-                <a:latin typeface="DM Sans" pitchFamily="34" charset="0"/>
-                <a:ea typeface="DM Sans" pitchFamily="34" charset="-122"/>
-                <a:cs typeface="DM Sans" pitchFamily="34" charset="-120"/>
-              </a:rPr>
-              <a:t>Vice-présidence : à pourvoir, par élection.</a:t>
-            </a:r>
-            <a:endParaRPr lang="en-US" sz="950" dirty="0"/>
-          </a:p>
-          <a:p>
-            <a:pPr marL="177800" indent="-177800">
-              <a:lnSpc>
-                <a:spcPct val="110000"/>
-              </a:lnSpc>
-              <a:spcAft>
-                <a:spcPts val="600"/>
-              </a:spcAft>
-              <a:buSzPct val="100000"/>
-              <a:buChar char="•"/>
-            </a:pPr>
-            <a:r>
-              <a:rPr lang="en-US" sz="950" dirty="0">
-                <a:solidFill>
-                  <a:srgbClr val="10241E"/>
-                </a:solidFill>
-                <a:latin typeface="DM Sans" pitchFamily="34" charset="0"/>
-                <a:ea typeface="DM Sans" pitchFamily="34" charset="-122"/>
-                <a:cs typeface="DM Sans" pitchFamily="34" charset="-120"/>
-              </a:rPr>
-              <a:t>Routes &amp; urbanisme — à pourvoir</a:t>
-            </a:r>
-            <a:endParaRPr lang="en-US" sz="950" dirty="0"/>
-          </a:p>
-          <a:p>
-            <a:pPr marL="177800" indent="-177800">
-              <a:lnSpc>
-                <a:spcPct val="110000"/>
-              </a:lnSpc>
-              <a:spcAft>
-                <a:spcPts val="600"/>
-              </a:spcAft>
-              <a:buSzPct val="100000"/>
-              <a:buChar char="•"/>
-            </a:pPr>
-            <a:r>
-              <a:rPr lang="en-US" sz="950" dirty="0">
-                <a:solidFill>
-                  <a:srgbClr val="10241E"/>
-                </a:solidFill>
-                <a:latin typeface="DM Sans" pitchFamily="34" charset="0"/>
-                <a:ea typeface="DM Sans" pitchFamily="34" charset="-122"/>
-                <a:cs typeface="DM Sans" pitchFamily="34" charset="-120"/>
-              </a:rPr>
-              <a:t>Urgences &amp; risques — à pourvoir</a:t>
-            </a:r>
-            <a:endParaRPr lang="en-US" sz="950" dirty="0"/>
-          </a:p>
-          <a:p>
-            <a:pPr marL="177800" indent="-177800">
-              <a:lnSpc>
-                <a:spcPct val="110000"/>
-              </a:lnSpc>
-              <a:spcAft>
-                <a:spcPts val="600"/>
-              </a:spcAft>
-              <a:buSzPct val="100000"/>
-              <a:buChar char="•"/>
-            </a:pPr>
-            <a:r>
-              <a:rPr lang="en-US" sz="950" dirty="0">
-                <a:solidFill>
-                  <a:srgbClr val="10241E"/>
-                </a:solidFill>
-                <a:latin typeface="DM Sans" pitchFamily="34" charset="0"/>
-                <a:ea typeface="DM Sans" pitchFamily="34" charset="-122"/>
-                <a:cs typeface="DM Sans" pitchFamily="34" charset="-120"/>
-              </a:rPr>
-              <a:t>Énergie — à pourvoir</a:t>
+              <a:t>Données et intelligence artificielle — Bonheur Allahaddje</a:t>
             </a:r>
             <a:endParaRPr lang="en-US" sz="950" dirty="0"/>
           </a:p>
@@ -13835,7 +13835,7 @@
                 <a:ea typeface="DM Sans" pitchFamily="34" charset="-122"/>
                 <a:cs typeface="DM Sans" pitchFamily="34" charset="-120"/>
               </a:rPr>
-              <a:t>Les vice-présidences de pôle à élire : quatre sur six (pôles III, IV, V, VI)</a:t>
+              <a:t>Les vice-présidences de pilier à élire : quatre sur six (piliers III, IV, V, VI)</a:t>
             </a:r>
             <a:endParaRPr lang="en-US" sz="1600" dirty="0"/>
           </a:p>
@@ -14066,7 +14066,7 @@
       </p:grpSpPr>
       <p:pic>
         <p:nvPicPr>
-          <p:cNvPr id="2" name="Image 0" descr="/home/claude/Lonodji/public/odeb/identite/odeb-lonodji-embleme-superposable-512.png">    </p:cNvPr>
+          <p:cNvPr id="2" name="Image 0" descr="/workspace/scratch/45770fcbf08b/lonodji/public/odeb/identite/odeb-lonodji-embleme-superposable-512.png">    </p:cNvPr>
           <p:cNvPicPr>
             <a:picLocks noChangeAspect="1"/>
           </p:cNvPicPr>
@@ -15374,7 +15374,7 @@
                 <a:ea typeface="DM Sans" pitchFamily="34" charset="-122"/>
                 <a:cs typeface="DM Sans" pitchFamily="34" charset="-120"/>
               </a:rPr>
-              <a:t>Thématique Recherche &amp; savoirs</a:t>
+              <a:t>Thématique Recherche et enseignement supérieur</a:t>
             </a:r>
             <a:endParaRPr lang="en-US" sz="1250" dirty="0"/>
           </a:p>
@@ -16310,7 +16310,7 @@
                 <a:ea typeface="DM Sans" pitchFamily="34" charset="-122"/>
                 <a:cs typeface="DM Sans" pitchFamily="34" charset="-120"/>
               </a:rPr>
-              <a:t>Pôle Numérique &amp; innovation</a:t>
+              <a:t>Numérique et innovation : leviers transversaux</a:t>
             </a:r>
             <a:endParaRPr lang="en-US" sz="1250" dirty="0"/>
           </a:p>
@@ -16812,7 +16812,7 @@
                 <a:ea typeface="DM Sans" pitchFamily="34" charset="-122"/>
                 <a:cs typeface="DM Sans" pitchFamily="34" charset="-120"/>
               </a:rPr>
-              <a:t>Thématique Réseau d’experts &amp; diaspora</a:t>
+              <a:t>Thématique Diaspora et partenariats</a:t>
             </a:r>
             <a:endParaRPr lang="en-US" sz="1250" dirty="0"/>
           </a:p>
@@ -18700,7 +18700,7 @@
                 <a:ea typeface="DM Sans" pitchFamily="34" charset="-122"/>
                 <a:cs typeface="DM Sans" pitchFamily="34" charset="-120"/>
               </a:rPr>
-              <a:t>Le programme rassemble ce qui fait la mémoire du pays bedjond — son histoire, ses lieux, ses lignées, ses livres, sa langue — et le rend accessible à ceux qui vivent à Bédjondo comme à la diaspora. Il prolonge le pôle I de l’association et les recommandations 2027-2030 : centre de documentation, atlas patrimonial, bibliothèque orale.</a:t>
+              <a:t>Le programme rassemble ce qui fait la mémoire du pays bedjond — son histoire, ses lieux, ses lignées, ses livres, sa langue — et le rend accessible à ceux qui vivent à Bédjondo comme à la diaspora. Il prolonge le pilier I de l’association et les recommandations 2027-2030 : centre de documentation, atlas patrimonial, bibliothèque orale.</a:t>
             </a:r>
             <a:endParaRPr lang="en-US" sz="1250" dirty="0"/>
           </a:p>

</xml_diff>